<commit_message>
Bring architecture doc, deck, and replication prompt current with reality
Architecture document/presentation (.md/.html/.docx/.pptx) updated for
the Chatbot/LLM Pentest capability and CredentialSet.extra_headers:
DAG node count (31->35), model/route/check-catalog/migration/RBAC
counts corrected throughout, new appendix rows, two regenerated Mermaid
diagrams (scan DAG, data model ER), and new FAQ entries. Also caught up
a few pre-existing staleness gaps found along the way (missing
open_redirect/api_version/csp_bypass nodes and catalog entries) since
they sit right next to what was being corrected anyway.

Added REPLICATION_PROMPT.md Part C covering both features in the same
depth as the existing parts, for reproducing this work on another
checkout of the codebase.

Co-Authored-By: Claude Sonnet 5 <noreply@anthropic.com>
Claude-Session: https://claude.ai/code/session_01MUFb1xr3BvwaLMqsqnAi7g
</commit_message>
<xml_diff>
--- a/docs/architecture-overview/Verdikt_Presentation.pptx
+++ b/docs/architecture-overview/Verdikt_Presentation.pptx
@@ -20,6 +20,7 @@
     <p:sldId id="267" r:id="rId18"/>
     <p:sldId id="268" r:id="rId19"/>
     <p:sldId id="269" r:id="rId20"/>
+    <p:sldId id="278" r:id="rId29"/>
     <p:sldId id="270" r:id="rId21"/>
     <p:sldId id="271" r:id="rId22"/>
     <p:sldId id="272" r:id="rId23"/>
@@ -3888,6 +3889,42 @@
               <a:t>•  WebSocket security, business logic (race conditions, workflow, mass assignment)</a:t>
             </a:r>
           </a:p>
+          <a:p>
+            <a:pPr>
+              <a:lnSpc>
+                <a:spcPct val="125000"/>
+              </a:lnSpc>
+              <a:spcAft>
+                <a:spcPts val="1000"/>
+              </a:spcAft>
+              <a:defRPr sz="1400" b="0">
+                <a:solidFill>
+                  <a:srgbClr val="1C1E21"/>
+                </a:solidFill>
+              </a:defRPr>
+            </a:pPr>
+            <a:r>
+              <a:t>•  LLM / Chatbot Pentest — OWASP LLM Top 10 2026 + Agentic Top 10 2026: prompt injection, hidden-context extraction, improper output handling, excessive agency, unexpected code execution</a:t>
+            </a:r>
+          </a:p>
+          <a:p>
+            <a:pPr>
+              <a:lnSpc>
+                <a:spcPct val="125000"/>
+              </a:lnSpc>
+              <a:spcAft>
+                <a:spcPts val="1000"/>
+              </a:spcAft>
+              <a:defRPr sz="1400" b="0">
+                <a:solidFill>
+                  <a:srgbClr val="1C1E21"/>
+                </a:solidFill>
+              </a:defRPr>
+            </a:pPr>
+            <a:r>
+              <a:t>•  API-specific &amp; CSP — deprecated API version data exposure, open redirect, JSONP-callback CSP bypass</a:t>
+            </a:r>
+          </a:p>
         </p:txBody>
       </p:sp>
       <p:sp>
@@ -5619,14 +5656,6 @@
 <file path=ppt/slides/slide16.xml><?xml version="1.0" encoding="utf-8"?>
 <p:sld xmlns:a="http://schemas.openxmlformats.org/drawingml/2006/main" xmlns:p="http://schemas.openxmlformats.org/presentationml/2006/main" xmlns:r="http://schemas.openxmlformats.org/officeDocument/2006/relationships">
   <p:cSld>
-    <p:bg>
-      <p:bgPr>
-        <a:solidFill>
-          <a:srgbClr val="FFFFFF"/>
-        </a:solidFill>
-        <a:effectLst/>
-      </p:bgPr>
-    </p:bg>
     <p:spTree>
       <p:nvGrpSpPr>
         <p:cNvPr id="1" name=""/>
@@ -5708,7 +5737,7 @@
               </a:defRPr>
             </a:pPr>
             <a:r>
-              <a:t>CROSS-PLATFORM, ONE COMMAND</a:t>
+              <a:t>DATA HANDLING &amp; SECURITY</a:t>
             </a:r>
           </a:p>
         </p:txBody>
@@ -5721,7 +5750,7 @@
         </p:nvSpPr>
         <p:spPr>
           <a:xfrm>
-            <a:off x="548640" y="457200"/>
+            <a:off x="548640" y="411480"/>
             <a:ext cx="11094415" cy="822960"/>
           </a:xfrm>
           <a:prstGeom prst="rect">
@@ -5744,35 +5773,160 @@
               </a:defRPr>
             </a:pPr>
             <a:r>
-              <a:t>Deployment</a:t>
-            </a:r>
-          </a:p>
-        </p:txBody>
-      </p:sp>
-      <p:pic>
-        <p:nvPicPr>
-          <p:cNvPr id="5" name="Picture 4" descr="06_deployment_topology.png"/>
-          <p:cNvPicPr>
-            <a:picLocks noChangeAspect="1"/>
-          </p:cNvPicPr>
-          <p:nvPr/>
-        </p:nvPicPr>
-        <p:blipFill>
-          <a:blip r:embed="rId2"/>
-          <a:stretch>
-            <a:fillRect/>
-          </a:stretch>
-        </p:blipFill>
-        <p:spPr>
-          <a:xfrm>
-            <a:off x="457200" y="1234440"/>
-            <a:ext cx="12533854" cy="4892040"/>
-          </a:xfrm>
-          <a:prstGeom prst="rect">
-            <a:avLst/>
-          </a:prstGeom>
-        </p:spPr>
-      </p:pic>
+              <a:t>What leaves your infrastructure, and what doesn't</a:t>
+            </a:r>
+          </a:p>
+        </p:txBody>
+      </p:sp>
+      <p:sp>
+        <p:nvSpPr>
+          <p:cNvPr id="5" name="TextBox 4"/>
+          <p:cNvSpPr txBox="1"/>
+          <p:nvPr/>
+        </p:nvSpPr>
+        <p:spPr>
+          <a:xfrm>
+            <a:off x="640080" y="1463040"/>
+            <a:ext cx="10911535" cy="4754880"/>
+          </a:xfrm>
+          <a:prstGeom prst="rect">
+            <a:avLst/>
+          </a:prstGeom>
+          <a:noFill/>
+        </p:spPr>
+        <p:txBody>
+          <a:bodyPr wrap="square">
+            <a:spAutoFit/>
+          </a:bodyPr>
+          <a:lstStyle/>
+          <a:p>
+            <a:pPr>
+              <a:lnSpc>
+                <a:spcPct val="125000"/>
+              </a:lnSpc>
+              <a:spcAft>
+                <a:spcPts val="1000"/>
+              </a:spcAft>
+              <a:defRPr sz="1600" b="0">
+                <a:solidFill>
+                  <a:srgbClr val="1C1E21"/>
+                </a:solidFill>
+              </a:defRPr>
+            </a:pPr>
+            <a:r>
+              <a:t>•  Multi-tenant isolation — every org_id-scoped resource chain (Project → Version → ScanRun → Finding) is enforced at the query layer, not just the UI</a:t>
+            </a:r>
+          </a:p>
+          <a:p>
+            <a:pPr>
+              <a:lnSpc>
+                <a:spcPct val="125000"/>
+              </a:lnSpc>
+              <a:spcAft>
+                <a:spcPts val="1000"/>
+              </a:spcAft>
+              <a:defRPr sz="1600" b="0">
+                <a:solidFill>
+                  <a:srgbClr val="1C1E21"/>
+                </a:solidFill>
+              </a:defRPr>
+            </a:pPr>
+            <a:r>
+              <a:t>•  Scope enforcement — ScopedHttpClient blocks any request outside a Version's declared scope; a scan can't wander off or exfiltrate to unauthorized infrastructure</a:t>
+            </a:r>
+          </a:p>
+          <a:p>
+            <a:pPr>
+              <a:lnSpc>
+                <a:spcPct val="125000"/>
+              </a:lnSpc>
+              <a:spcAft>
+                <a:spcPts val="1000"/>
+              </a:spcAft>
+              <a:defRPr sz="1600" b="0">
+                <a:solidFill>
+                  <a:srgbClr val="1C1E21"/>
+                </a:solidFill>
+              </a:defRPr>
+            </a:pPr>
+            <a:r>
+              <a:t>•  Credential encryption — every stored secret envelope-encrypted via KMS before touching the database; plaintext never logged or echoed back</a:t>
+            </a:r>
+          </a:p>
+          <a:p>
+            <a:pPr>
+              <a:lnSpc>
+                <a:spcPct val="125000"/>
+              </a:lnSpc>
+              <a:spcAft>
+                <a:spcPts val="1000"/>
+              </a:spcAft>
+              <a:defRPr sz="1600" b="0">
+                <a:solidFill>
+                  <a:srgbClr val="1C1E21"/>
+                </a:solidFill>
+              </a:defRPr>
+            </a:pPr>
+            <a:r>
+              <a:t>•  The one real third-party data flow — AI-assisted triage sends truncated request/response snippets to whichever LLM provider is configured for that scan</a:t>
+            </a:r>
+          </a:p>
+          <a:p>
+            <a:pPr>
+              <a:lnSpc>
+                <a:spcPct val="125000"/>
+              </a:lnSpc>
+              <a:spcAft>
+                <a:spcPts val="1000"/>
+              </a:spcAft>
+              <a:defRPr sz="1600" b="0">
+                <a:solidFill>
+                  <a:srgbClr val="1C1E21"/>
+                </a:solidFill>
+              </a:defRPr>
+            </a:pPr>
+            <a:r>
+              <a:t>•  Close it off entirely — point the AI provider at a self-hosted/on-prem endpoint, or run with no AI provider at all; deterministic checks (most of the catalog) still produce real, confirmed findings</a:t>
+            </a:r>
+          </a:p>
+          <a:p>
+            <a:pPr>
+              <a:lnSpc>
+                <a:spcPct val="125000"/>
+              </a:lnSpc>
+              <a:spcAft>
+                <a:spcPts val="1000"/>
+              </a:spcAft>
+              <a:defRPr sz="1600" b="0">
+                <a:solidFill>
+                  <a:srgbClr val="1C1E21"/>
+                </a:solidFill>
+              </a:defRPr>
+            </a:pPr>
+            <a:r>
+              <a:t>•  Evidence storage — screenshots and captured traffic go to local disk or S3, under the deploying organization's own infrastructure</a:t>
+            </a:r>
+          </a:p>
+          <a:p>
+            <a:pPr>
+              <a:lnSpc>
+                <a:spcPct val="125000"/>
+              </a:lnSpc>
+              <a:spcAft>
+                <a:spcPts val="1000"/>
+              </a:spcAft>
+              <a:defRPr sz="1600" b="0">
+                <a:solidFill>
+                  <a:srgbClr val="1C1E21"/>
+                </a:solidFill>
+              </a:defRPr>
+            </a:pPr>
+            <a:r>
+              <a:t>•  No telemetry — no analytics/telemetry SDK of any kind anywhere in the codebase</a:t>
+            </a:r>
+          </a:p>
+        </p:txBody>
+      </p:sp>
       <p:sp>
         <p:nvSpPr>
           <p:cNvPr id="6" name="TextBox 5"/>
@@ -5781,8 +5935,8 @@
         </p:nvSpPr>
         <p:spPr>
           <a:xfrm>
-            <a:off x="548640" y="6172200"/>
-            <a:ext cx="11094415" cy="365760"/>
+            <a:off x="11094415" y="6400800"/>
+            <a:ext cx="822960" cy="320040"/>
           </a:xfrm>
           <a:prstGeom prst="rect">
             <a:avLst/>
@@ -5795,41 +5949,6 @@
           </a:bodyPr>
           <a:lstStyle/>
           <a:p>
-            <a:pPr algn="ctr">
-              <a:defRPr sz="1100" i="1">
-                <a:solidFill>
-                  <a:srgbClr val="5B6270"/>
-                </a:solidFill>
-              </a:defRPr>
-            </a:pPr>
-            <a:r>
-              <a:t>docker compose up — verified end-to-end on a fresh environment; migrations run automatically; works identically on macOS, Linux, and Windows.</a:t>
-            </a:r>
-          </a:p>
-        </p:txBody>
-      </p:sp>
-      <p:sp>
-        <p:nvSpPr>
-          <p:cNvPr id="7" name="TextBox 6"/>
-          <p:cNvSpPr txBox="1"/>
-          <p:nvPr/>
-        </p:nvSpPr>
-        <p:spPr>
-          <a:xfrm>
-            <a:off x="11094415" y="6400800"/>
-            <a:ext cx="822960" cy="320040"/>
-          </a:xfrm>
-          <a:prstGeom prst="rect">
-            <a:avLst/>
-          </a:prstGeom>
-          <a:noFill/>
-        </p:spPr>
-        <p:txBody>
-          <a:bodyPr wrap="none">
-            <a:spAutoFit/>
-          </a:bodyPr>
-          <a:lstStyle/>
-          <a:p>
             <a:pPr algn="r">
               <a:defRPr sz="1000">
                 <a:solidFill>
@@ -5845,7 +5964,7 @@
       </p:sp>
       <p:sp>
         <p:nvSpPr>
-          <p:cNvPr id="8" name="TextBox 7"/>
+          <p:cNvPr id="7" name="TextBox 6"/>
           <p:cNvSpPr txBox="1"/>
           <p:nvPr/>
         </p:nvSpPr>
@@ -5978,7 +6097,7 @@
               </a:defRPr>
             </a:pPr>
             <a:r>
-              <a:t>BY THE NUMBERS</a:t>
+              <a:t>CROSS-PLATFORM, ONE COMMAND</a:t>
             </a:r>
           </a:p>
         </p:txBody>
@@ -5991,7 +6110,7 @@
         </p:nvSpPr>
         <p:spPr>
           <a:xfrm>
-            <a:off x="548640" y="411480"/>
+            <a:off x="548640" y="457200"/>
             <a:ext cx="11094415" cy="822960"/>
           </a:xfrm>
           <a:prstGeom prst="rect">
@@ -6006,7 +6125,7 @@
           <a:lstStyle/>
           <a:p>
             <a:pPr>
-              <a:defRPr sz="2800" b="1">
+              <a:defRPr sz="2600" b="1">
                 <a:solidFill>
                   <a:srgbClr val="1C1E21"/>
                 </a:solidFill>
@@ -6014,565 +6133,45 @@
               </a:defRPr>
             </a:pPr>
             <a:r>
-              <a:t>The codebase, counted — not estimated</a:t>
-            </a:r>
-          </a:p>
-        </p:txBody>
-      </p:sp>
-      <p:sp>
-        <p:nvSpPr>
-          <p:cNvPr id="5" name="Rounded Rectangle 4"/>
-          <p:cNvSpPr/>
-          <p:nvPr/>
-        </p:nvSpPr>
-        <p:spPr>
-          <a:xfrm>
-            <a:off x="457200" y="1737360"/>
-            <a:ext cx="2651760" cy="1554480"/>
-          </a:xfrm>
-          <a:prstGeom prst="roundRect">
-            <a:avLst/>
-          </a:prstGeom>
-          <a:solidFill>
-            <a:srgbClr val="F3EEFB"/>
-          </a:solidFill>
-          <a:ln w="15875">
-            <a:solidFill>
-              <a:srgbClr val="E3E5E9"/>
-            </a:solidFill>
-          </a:ln>
-          <a:effectLst/>
-        </p:spPr>
-        <p:style>
-          <a:lnRef idx="1">
-            <a:schemeClr val="accent1"/>
-          </a:lnRef>
-          <a:fillRef idx="3">
-            <a:schemeClr val="accent1"/>
-          </a:fillRef>
-          <a:effectRef idx="2">
-            <a:schemeClr val="accent1"/>
-          </a:effectRef>
-          <a:fontRef idx="minor">
-            <a:schemeClr val="lt1"/>
-          </a:fontRef>
-        </p:style>
-        <p:txBody>
-          <a:bodyPr rtlCol="0" anchor="ctr" wrap="square" lIns="45720" rIns="45720"/>
-          <a:lstStyle/>
-          <a:p>
-            <a:pPr algn="ctr">
-              <a:defRPr sz="3400" b="1">
-                <a:solidFill>
-                  <a:srgbClr val="6D28D9"/>
-                </a:solidFill>
-              </a:defRPr>
-            </a:pPr>
-            <a:r>
-              <a:t>52</a:t>
-            </a:r>
-          </a:p>
-          <a:p>
-            <a:pPr algn="ctr">
-              <a:defRPr sz="1200">
-                <a:solidFill>
-                  <a:srgbClr val="1C1E21"/>
-                </a:solidFill>
-              </a:defRPr>
-            </a:pPr>
-            <a:r>
-              <a:t>agent files</a:t>
-            </a:r>
-            <a:br/>
-            <a:r>
-              <a:t>(31 wired into the scan graph)</a:t>
-            </a:r>
-          </a:p>
-        </p:txBody>
-      </p:sp>
-      <p:sp>
-        <p:nvSpPr>
-          <p:cNvPr id="6" name="Rounded Rectangle 5"/>
-          <p:cNvSpPr/>
-          <p:nvPr/>
-        </p:nvSpPr>
-        <p:spPr>
-          <a:xfrm>
-            <a:off x="3246120" y="1737360"/>
-            <a:ext cx="2651760" cy="1554480"/>
-          </a:xfrm>
-          <a:prstGeom prst="roundRect">
-            <a:avLst/>
-          </a:prstGeom>
-          <a:solidFill>
-            <a:srgbClr val="F3EEFB"/>
-          </a:solidFill>
-          <a:ln w="15875">
-            <a:solidFill>
-              <a:srgbClr val="E3E5E9"/>
-            </a:solidFill>
-          </a:ln>
-          <a:effectLst/>
-        </p:spPr>
-        <p:style>
-          <a:lnRef idx="1">
-            <a:schemeClr val="accent1"/>
-          </a:lnRef>
-          <a:fillRef idx="3">
-            <a:schemeClr val="accent1"/>
-          </a:fillRef>
-          <a:effectRef idx="2">
-            <a:schemeClr val="accent1"/>
-          </a:effectRef>
-          <a:fontRef idx="minor">
-            <a:schemeClr val="lt1"/>
-          </a:fontRef>
-        </p:style>
-        <p:txBody>
-          <a:bodyPr rtlCol="0" anchor="ctr" wrap="square" lIns="45720" rIns="45720"/>
-          <a:lstStyle/>
-          <a:p>
-            <a:pPr algn="ctr">
-              <a:defRPr sz="3400" b="1">
-                <a:solidFill>
-                  <a:srgbClr val="6D28D9"/>
-                </a:solidFill>
-              </a:defRPr>
-            </a:pPr>
-            <a:r>
-              <a:t>30</a:t>
-            </a:r>
-          </a:p>
-          <a:p>
-            <a:pPr algn="ctr">
-              <a:defRPr sz="1200">
-                <a:solidFill>
-                  <a:srgbClr val="1C1E21"/>
-                </a:solidFill>
-              </a:defRPr>
-            </a:pPr>
-            <a:r>
-              <a:t>API route modules</a:t>
-            </a:r>
-          </a:p>
-        </p:txBody>
-      </p:sp>
-      <p:sp>
-        <p:nvSpPr>
-          <p:cNvPr id="7" name="Rounded Rectangle 6"/>
-          <p:cNvSpPr/>
-          <p:nvPr/>
-        </p:nvSpPr>
-        <p:spPr>
-          <a:xfrm>
-            <a:off x="6035040" y="1737360"/>
-            <a:ext cx="2651760" cy="1554480"/>
-          </a:xfrm>
-          <a:prstGeom prst="roundRect">
-            <a:avLst/>
-          </a:prstGeom>
-          <a:solidFill>
-            <a:srgbClr val="F3EEFB"/>
-          </a:solidFill>
-          <a:ln w="15875">
-            <a:solidFill>
-              <a:srgbClr val="E3E5E9"/>
-            </a:solidFill>
-          </a:ln>
-          <a:effectLst/>
-        </p:spPr>
-        <p:style>
-          <a:lnRef idx="1">
-            <a:schemeClr val="accent1"/>
-          </a:lnRef>
-          <a:fillRef idx="3">
-            <a:schemeClr val="accent1"/>
-          </a:fillRef>
-          <a:effectRef idx="2">
-            <a:schemeClr val="accent1"/>
-          </a:effectRef>
-          <a:fontRef idx="minor">
-            <a:schemeClr val="lt1"/>
-          </a:fontRef>
-        </p:style>
-        <p:txBody>
-          <a:bodyPr rtlCol="0" anchor="ctr" wrap="square" lIns="45720" rIns="45720"/>
-          <a:lstStyle/>
-          <a:p>
-            <a:pPr algn="ctr">
-              <a:defRPr sz="3400" b="1">
-                <a:solidFill>
-                  <a:srgbClr val="6D28D9"/>
-                </a:solidFill>
-              </a:defRPr>
-            </a:pPr>
-            <a:r>
-              <a:t>~34</a:t>
-            </a:r>
-          </a:p>
-          <a:p>
-            <a:pPr algn="ctr">
-              <a:defRPr sz="1200">
-                <a:solidFill>
-                  <a:srgbClr val="1C1E21"/>
-                </a:solidFill>
-              </a:defRPr>
-            </a:pPr>
-            <a:r>
-              <a:t>persisted data models</a:t>
-            </a:r>
-          </a:p>
-        </p:txBody>
-      </p:sp>
-      <p:sp>
-        <p:nvSpPr>
-          <p:cNvPr id="8" name="Rounded Rectangle 7"/>
-          <p:cNvSpPr/>
-          <p:nvPr/>
-        </p:nvSpPr>
-        <p:spPr>
-          <a:xfrm>
-            <a:off x="8823960" y="1737360"/>
-            <a:ext cx="2651760" cy="1554480"/>
-          </a:xfrm>
-          <a:prstGeom prst="roundRect">
-            <a:avLst/>
-          </a:prstGeom>
-          <a:solidFill>
-            <a:srgbClr val="F3EEFB"/>
-          </a:solidFill>
-          <a:ln w="15875">
-            <a:solidFill>
-              <a:srgbClr val="E3E5E9"/>
-            </a:solidFill>
-          </a:ln>
-          <a:effectLst/>
-        </p:spPr>
-        <p:style>
-          <a:lnRef idx="1">
-            <a:schemeClr val="accent1"/>
-          </a:lnRef>
-          <a:fillRef idx="3">
-            <a:schemeClr val="accent1"/>
-          </a:fillRef>
-          <a:effectRef idx="2">
-            <a:schemeClr val="accent1"/>
-          </a:effectRef>
-          <a:fontRef idx="minor">
-            <a:schemeClr val="lt1"/>
-          </a:fontRef>
-        </p:style>
-        <p:txBody>
-          <a:bodyPr rtlCol="0" anchor="ctr" wrap="square" lIns="45720" rIns="45720"/>
-          <a:lstStyle/>
-          <a:p>
-            <a:pPr algn="ctr">
-              <a:defRPr sz="3400" b="1">
-                <a:solidFill>
-                  <a:srgbClr val="6D28D9"/>
-                </a:solidFill>
-              </a:defRPr>
-            </a:pPr>
-            <a:r>
-              <a:t>10</a:t>
-            </a:r>
-          </a:p>
-          <a:p>
-            <a:pPr algn="ctr">
-              <a:defRPr sz="1200">
-                <a:solidFill>
-                  <a:srgbClr val="1C1E21"/>
-                </a:solidFill>
-              </a:defRPr>
-            </a:pPr>
-            <a:r>
-              <a:t>external integrations</a:t>
-            </a:r>
-          </a:p>
-        </p:txBody>
-      </p:sp>
-      <p:sp>
-        <p:nvSpPr>
-          <p:cNvPr id="9" name="Rounded Rectangle 8"/>
-          <p:cNvSpPr/>
-          <p:nvPr/>
-        </p:nvSpPr>
-        <p:spPr>
-          <a:xfrm>
-            <a:off x="457200" y="3474720"/>
-            <a:ext cx="2651760" cy="1554480"/>
-          </a:xfrm>
-          <a:prstGeom prst="roundRect">
-            <a:avLst/>
-          </a:prstGeom>
-          <a:solidFill>
-            <a:srgbClr val="F3EEFB"/>
-          </a:solidFill>
-          <a:ln w="15875">
-            <a:solidFill>
-              <a:srgbClr val="E3E5E9"/>
-            </a:solidFill>
-          </a:ln>
-          <a:effectLst/>
-        </p:spPr>
-        <p:style>
-          <a:lnRef idx="1">
-            <a:schemeClr val="accent1"/>
-          </a:lnRef>
-          <a:fillRef idx="3">
-            <a:schemeClr val="accent1"/>
-          </a:fillRef>
-          <a:effectRef idx="2">
-            <a:schemeClr val="accent1"/>
-          </a:effectRef>
-          <a:fontRef idx="minor">
-            <a:schemeClr val="lt1"/>
-          </a:fontRef>
-        </p:style>
-        <p:txBody>
-          <a:bodyPr rtlCol="0" anchor="ctr" wrap="square" lIns="45720" rIns="45720"/>
-          <a:lstStyle/>
-          <a:p>
-            <a:pPr algn="ctr">
-              <a:defRPr sz="3400" b="1">
-                <a:solidFill>
-                  <a:srgbClr val="6D28D9"/>
-                </a:solidFill>
-              </a:defRPr>
-            </a:pPr>
-            <a:r>
-              <a:t>39</a:t>
-            </a:r>
-          </a:p>
-          <a:p>
-            <a:pPr algn="ctr">
-              <a:defRPr sz="1200">
-                <a:solidFill>
-                  <a:srgbClr val="1C1E21"/>
-                </a:solidFill>
-              </a:defRPr>
-            </a:pPr>
-            <a:r>
-              <a:t>static check IDs</a:t>
-            </a:r>
-            <a:br/>
-            <a:r>
-              <a:t>across 18 YAML catalogs</a:t>
-            </a:r>
-          </a:p>
-        </p:txBody>
-      </p:sp>
-      <p:sp>
-        <p:nvSpPr>
-          <p:cNvPr id="10" name="Rounded Rectangle 9"/>
-          <p:cNvSpPr/>
-          <p:nvPr/>
-        </p:nvSpPr>
-        <p:spPr>
-          <a:xfrm>
-            <a:off x="3246120" y="3474720"/>
-            <a:ext cx="2651760" cy="1554480"/>
-          </a:xfrm>
-          <a:prstGeom prst="roundRect">
-            <a:avLst/>
-          </a:prstGeom>
-          <a:solidFill>
-            <a:srgbClr val="F3EEFB"/>
-          </a:solidFill>
-          <a:ln w="15875">
-            <a:solidFill>
-              <a:srgbClr val="E3E5E9"/>
-            </a:solidFill>
-          </a:ln>
-          <a:effectLst/>
-        </p:spPr>
-        <p:style>
-          <a:lnRef idx="1">
-            <a:schemeClr val="accent1"/>
-          </a:lnRef>
-          <a:fillRef idx="3">
-            <a:schemeClr val="accent1"/>
-          </a:fillRef>
-          <a:effectRef idx="2">
-            <a:schemeClr val="accent1"/>
-          </a:effectRef>
-          <a:fontRef idx="minor">
-            <a:schemeClr val="lt1"/>
-          </a:fontRef>
-        </p:style>
-        <p:txBody>
-          <a:bodyPr rtlCol="0" anchor="ctr" wrap="square" lIns="45720" rIns="45720"/>
-          <a:lstStyle/>
-          <a:p>
-            <a:pPr algn="ctr">
-              <a:defRPr sz="3400" b="1">
-                <a:solidFill>
-                  <a:srgbClr val="6D28D9"/>
-                </a:solidFill>
-              </a:defRPr>
-            </a:pPr>
-            <a:r>
-              <a:t>36</a:t>
-            </a:r>
-          </a:p>
-          <a:p>
-            <a:pPr algn="ctr">
-              <a:defRPr sz="1200">
-                <a:solidFill>
-                  <a:srgbClr val="1C1E21"/>
-                </a:solidFill>
-              </a:defRPr>
-            </a:pPr>
-            <a:r>
-              <a:t>Alembic migrations</a:t>
-            </a:r>
-          </a:p>
-        </p:txBody>
-      </p:sp>
-      <p:sp>
-        <p:nvSpPr>
-          <p:cNvPr id="11" name="Rounded Rectangle 10"/>
-          <p:cNvSpPr/>
-          <p:nvPr/>
-        </p:nvSpPr>
-        <p:spPr>
-          <a:xfrm>
-            <a:off x="6035040" y="3474720"/>
-            <a:ext cx="2651760" cy="1554480"/>
-          </a:xfrm>
-          <a:prstGeom prst="roundRect">
-            <a:avLst/>
-          </a:prstGeom>
-          <a:solidFill>
-            <a:srgbClr val="F3EEFB"/>
-          </a:solidFill>
-          <a:ln w="15875">
-            <a:solidFill>
-              <a:srgbClr val="E3E5E9"/>
-            </a:solidFill>
-          </a:ln>
-          <a:effectLst/>
-        </p:spPr>
-        <p:style>
-          <a:lnRef idx="1">
-            <a:schemeClr val="accent1"/>
-          </a:lnRef>
-          <a:fillRef idx="3">
-            <a:schemeClr val="accent1"/>
-          </a:fillRef>
-          <a:effectRef idx="2">
-            <a:schemeClr val="accent1"/>
-          </a:effectRef>
-          <a:fontRef idx="minor">
-            <a:schemeClr val="lt1"/>
-          </a:fontRef>
-        </p:style>
-        <p:txBody>
-          <a:bodyPr rtlCol="0" anchor="ctr" wrap="square" lIns="45720" rIns="45720"/>
-          <a:lstStyle/>
-          <a:p>
-            <a:pPr algn="ctr">
-              <a:defRPr sz="3400" b="1">
-                <a:solidFill>
-                  <a:srgbClr val="6D28D9"/>
-                </a:solidFill>
-              </a:defRPr>
-            </a:pPr>
-            <a:r>
-              <a:t>20×4</a:t>
-            </a:r>
-          </a:p>
-          <a:p>
-            <a:pPr algn="ctr">
-              <a:defRPr sz="1200">
-                <a:solidFill>
-                  <a:srgbClr val="1C1E21"/>
-                </a:solidFill>
-              </a:defRPr>
-            </a:pPr>
-            <a:r>
-              <a:t>RBAC resources × actions</a:t>
-            </a:r>
-          </a:p>
-        </p:txBody>
-      </p:sp>
-      <p:sp>
-        <p:nvSpPr>
-          <p:cNvPr id="12" name="Rounded Rectangle 11"/>
-          <p:cNvSpPr/>
-          <p:nvPr/>
-        </p:nvSpPr>
-        <p:spPr>
-          <a:xfrm>
-            <a:off x="8823960" y="3474720"/>
-            <a:ext cx="2651760" cy="1554480"/>
-          </a:xfrm>
-          <a:prstGeom prst="roundRect">
-            <a:avLst/>
-          </a:prstGeom>
-          <a:solidFill>
-            <a:srgbClr val="F3EEFB"/>
-          </a:solidFill>
-          <a:ln w="15875">
-            <a:solidFill>
-              <a:srgbClr val="E3E5E9"/>
-            </a:solidFill>
-          </a:ln>
-          <a:effectLst/>
-        </p:spPr>
-        <p:style>
-          <a:lnRef idx="1">
-            <a:schemeClr val="accent1"/>
-          </a:lnRef>
-          <a:fillRef idx="3">
-            <a:schemeClr val="accent1"/>
-          </a:fillRef>
-          <a:effectRef idx="2">
-            <a:schemeClr val="accent1"/>
-          </a:effectRef>
-          <a:fontRef idx="minor">
-            <a:schemeClr val="lt1"/>
-          </a:fontRef>
-        </p:style>
-        <p:txBody>
-          <a:bodyPr rtlCol="0" anchor="ctr" wrap="square" lIns="45720" rIns="45720"/>
-          <a:lstStyle/>
-          <a:p>
-            <a:pPr algn="ctr">
-              <a:defRPr sz="3400" b="1">
-                <a:solidFill>
-                  <a:srgbClr val="6D28D9"/>
-                </a:solidFill>
-              </a:defRPr>
-            </a:pPr>
-            <a:r>
-              <a:t>667</a:t>
-            </a:r>
-          </a:p>
-          <a:p>
-            <a:pPr algn="ctr">
-              <a:defRPr sz="1200">
-                <a:solidFill>
-                  <a:srgbClr val="1C1E21"/>
-                </a:solidFill>
-              </a:defRPr>
-            </a:pPr>
-            <a:r>
-              <a:t>tests across 119 files</a:t>
-            </a:r>
-          </a:p>
-        </p:txBody>
-      </p:sp>
-      <p:sp>
-        <p:nvSpPr>
-          <p:cNvPr id="13" name="TextBox 12"/>
+              <a:t>Deployment</a:t>
+            </a:r>
+          </a:p>
+        </p:txBody>
+      </p:sp>
+      <p:pic>
+        <p:nvPicPr>
+          <p:cNvPr id="5" name="Picture 4" descr="06_deployment_topology.png"/>
+          <p:cNvPicPr>
+            <a:picLocks noChangeAspect="1"/>
+          </p:cNvPicPr>
+          <p:nvPr/>
+        </p:nvPicPr>
+        <p:blipFill>
+          <a:blip r:embed="rId2"/>
+          <a:stretch>
+            <a:fillRect/>
+          </a:stretch>
+        </p:blipFill>
+        <p:spPr>
+          <a:xfrm>
+            <a:off x="457200" y="1234440"/>
+            <a:ext cx="12533854" cy="4892040"/>
+          </a:xfrm>
+          <a:prstGeom prst="rect">
+            <a:avLst/>
+          </a:prstGeom>
+        </p:spPr>
+      </p:pic>
+      <p:sp>
+        <p:nvSpPr>
+          <p:cNvPr id="6" name="TextBox 5"/>
           <p:cNvSpPr txBox="1"/>
           <p:nvPr/>
         </p:nvSpPr>
         <p:spPr>
           <a:xfrm>
-            <a:off x="548640" y="6035040"/>
-            <a:ext cx="11094415" cy="457200"/>
+            <a:off x="548640" y="6172200"/>
+            <a:ext cx="11094415" cy="365760"/>
           </a:xfrm>
           <a:prstGeom prst="rect">
             <a:avLst/>
@@ -6586,21 +6185,21 @@
           <a:lstStyle/>
           <a:p>
             <a:pPr algn="ctr">
-              <a:defRPr i="1" sz="1200">
+              <a:defRPr sz="1100" i="1">
                 <a:solidFill>
                   <a:srgbClr val="5B6270"/>
                 </a:solidFill>
               </a:defRPr>
             </a:pPr>
             <a:r>
-              <a:t>Verified by direct code inspection and by running the test collector — not estimated.</a:t>
-            </a:r>
-          </a:p>
-        </p:txBody>
-      </p:sp>
-      <p:sp>
-        <p:nvSpPr>
-          <p:cNvPr id="14" name="TextBox 13"/>
+              <a:t>docker compose up — verified end-to-end on a fresh environment; migrations run automatically; works identically on macOS, Linux, and Windows.</a:t>
+            </a:r>
+          </a:p>
+        </p:txBody>
+      </p:sp>
+      <p:sp>
+        <p:nvSpPr>
+          <p:cNvPr id="7" name="TextBox 6"/>
           <p:cNvSpPr txBox="1"/>
           <p:nvPr/>
         </p:nvSpPr>
@@ -6635,7 +6234,7 @@
       </p:sp>
       <p:sp>
         <p:nvSpPr>
-          <p:cNvPr id="15" name="TextBox 14"/>
+          <p:cNvPr id="8" name="TextBox 7"/>
           <p:cNvSpPr txBox="1"/>
           <p:nvPr/>
         </p:nvSpPr>
@@ -6768,7 +6367,7 @@
               </a:defRPr>
             </a:pPr>
             <a:r>
-              <a:t>AN HONEST LOOK</a:t>
+              <a:t>BY THE NUMBERS</a:t>
             </a:r>
           </a:p>
         </p:txBody>
@@ -6804,7 +6403,7 @@
               </a:defRPr>
             </a:pPr>
             <a:r>
-              <a:t>Spec vs. reality</a:t>
+              <a:t>The codebase, counted — not estimated</a:t>
             </a:r>
           </a:p>
         </p:txBody>
@@ -6817,8 +6416,8 @@
         </p:nvSpPr>
         <p:spPr>
           <a:xfrm>
-            <a:off x="548640" y="1554480"/>
-            <a:ext cx="5394960" cy="4480560"/>
+            <a:off x="457200" y="1737360"/>
+            <a:ext cx="2651760" cy="1554480"/>
           </a:xfrm>
           <a:prstGeom prst="roundRect">
             <a:avLst/>
@@ -6828,7 +6427,7 @@
           </a:solidFill>
           <a:ln w="15875">
             <a:solidFill>
-              <a:srgbClr val="6D28D9"/>
+              <a:srgbClr val="E3E5E9"/>
             </a:solidFill>
           </a:ln>
           <a:effectLst/>
@@ -6852,12 +6451,31 @@
           <a:lstStyle/>
           <a:p>
             <a:pPr algn="ctr">
-              <a:defRPr sz="1300" b="0">
+              <a:defRPr sz="3400" b="1">
+                <a:solidFill>
+                  <a:srgbClr val="6D28D9"/>
+                </a:solidFill>
+              </a:defRPr>
+            </a:pPr>
+            <a:r>
+              <a:t>57</a:t>
+            </a:r>
+          </a:p>
+          <a:p>
+            <a:pPr algn="ctr">
+              <a:defRPr sz="1200">
                 <a:solidFill>
                   <a:srgbClr val="1C1E21"/>
                 </a:solidFill>
               </a:defRPr>
             </a:pPr>
+            <a:r>
+              <a:t>agent files</a:t>
+            </a:r>
+            <a:br/>
+            <a:r>
+              <a:t>(35 wired into the scan graph)</a:t>
+            </a:r>
           </a:p>
         </p:txBody>
       </p:sp>
@@ -6869,8 +6487,8 @@
         </p:nvSpPr>
         <p:spPr>
           <a:xfrm>
-            <a:off x="6217920" y="1554480"/>
-            <a:ext cx="5394960" cy="4480560"/>
+            <a:off x="3246120" y="1737360"/>
+            <a:ext cx="2651760" cy="1554480"/>
           </a:xfrm>
           <a:prstGeom prst="roundRect">
             <a:avLst/>
@@ -6880,7 +6498,7 @@
           </a:solidFill>
           <a:ln w="15875">
             <a:solidFill>
-              <a:srgbClr val="6D28D9"/>
+              <a:srgbClr val="E3E5E9"/>
             </a:solidFill>
           </a:ln>
           <a:effectLst/>
@@ -6904,227 +6522,446 @@
           <a:lstStyle/>
           <a:p>
             <a:pPr algn="ctr">
-              <a:defRPr sz="1300" b="0">
+              <a:defRPr sz="3400" b="1">
+                <a:solidFill>
+                  <a:srgbClr val="6D28D9"/>
+                </a:solidFill>
+              </a:defRPr>
+            </a:pPr>
+            <a:r>
+              <a:t>32</a:t>
+            </a:r>
+          </a:p>
+          <a:p>
+            <a:pPr algn="ctr">
+              <a:defRPr sz="1200">
                 <a:solidFill>
                   <a:srgbClr val="1C1E21"/>
                 </a:solidFill>
               </a:defRPr>
             </a:pPr>
-          </a:p>
-        </p:txBody>
-      </p:sp>
-      <p:sp>
-        <p:nvSpPr>
-          <p:cNvPr id="7" name="TextBox 6"/>
+            <a:r>
+              <a:t>API route modules</a:t>
+            </a:r>
+          </a:p>
+        </p:txBody>
+      </p:sp>
+      <p:sp>
+        <p:nvSpPr>
+          <p:cNvPr id="7" name="Rounded Rectangle 6"/>
+          <p:cNvSpPr/>
+          <p:nvPr/>
+        </p:nvSpPr>
+        <p:spPr>
+          <a:xfrm>
+            <a:off x="6035040" y="1737360"/>
+            <a:ext cx="2651760" cy="1554480"/>
+          </a:xfrm>
+          <a:prstGeom prst="roundRect">
+            <a:avLst/>
+          </a:prstGeom>
+          <a:solidFill>
+            <a:srgbClr val="F3EEFB"/>
+          </a:solidFill>
+          <a:ln w="15875">
+            <a:solidFill>
+              <a:srgbClr val="E3E5E9"/>
+            </a:solidFill>
+          </a:ln>
+          <a:effectLst/>
+        </p:spPr>
+        <p:style>
+          <a:lnRef idx="1">
+            <a:schemeClr val="accent1"/>
+          </a:lnRef>
+          <a:fillRef idx="3">
+            <a:schemeClr val="accent1"/>
+          </a:fillRef>
+          <a:effectRef idx="2">
+            <a:schemeClr val="accent1"/>
+          </a:effectRef>
+          <a:fontRef idx="minor">
+            <a:schemeClr val="lt1"/>
+          </a:fontRef>
+        </p:style>
+        <p:txBody>
+          <a:bodyPr rtlCol="0" anchor="ctr" wrap="square" lIns="45720" rIns="45720"/>
+          <a:lstStyle/>
+          <a:p>
+            <a:pPr algn="ctr">
+              <a:defRPr sz="3400" b="1">
+                <a:solidFill>
+                  <a:srgbClr val="6D28D9"/>
+                </a:solidFill>
+              </a:defRPr>
+            </a:pPr>
+            <a:r>
+              <a:t>36</a:t>
+            </a:r>
+          </a:p>
+          <a:p>
+            <a:pPr algn="ctr">
+              <a:defRPr sz="1200">
+                <a:solidFill>
+                  <a:srgbClr val="1C1E21"/>
+                </a:solidFill>
+              </a:defRPr>
+            </a:pPr>
+            <a:r>
+              <a:t>persisted data models</a:t>
+            </a:r>
+          </a:p>
+        </p:txBody>
+      </p:sp>
+      <p:sp>
+        <p:nvSpPr>
+          <p:cNvPr id="8" name="Rounded Rectangle 7"/>
+          <p:cNvSpPr/>
+          <p:nvPr/>
+        </p:nvSpPr>
+        <p:spPr>
+          <a:xfrm>
+            <a:off x="8823960" y="1737360"/>
+            <a:ext cx="2651760" cy="1554480"/>
+          </a:xfrm>
+          <a:prstGeom prst="roundRect">
+            <a:avLst/>
+          </a:prstGeom>
+          <a:solidFill>
+            <a:srgbClr val="F3EEFB"/>
+          </a:solidFill>
+          <a:ln w="15875">
+            <a:solidFill>
+              <a:srgbClr val="E3E5E9"/>
+            </a:solidFill>
+          </a:ln>
+          <a:effectLst/>
+        </p:spPr>
+        <p:style>
+          <a:lnRef idx="1">
+            <a:schemeClr val="accent1"/>
+          </a:lnRef>
+          <a:fillRef idx="3">
+            <a:schemeClr val="accent1"/>
+          </a:fillRef>
+          <a:effectRef idx="2">
+            <a:schemeClr val="accent1"/>
+          </a:effectRef>
+          <a:fontRef idx="minor">
+            <a:schemeClr val="lt1"/>
+          </a:fontRef>
+        </p:style>
+        <p:txBody>
+          <a:bodyPr rtlCol="0" anchor="ctr" wrap="square" lIns="45720" rIns="45720"/>
+          <a:lstStyle/>
+          <a:p>
+            <a:pPr algn="ctr">
+              <a:defRPr sz="3400" b="1">
+                <a:solidFill>
+                  <a:srgbClr val="6D28D9"/>
+                </a:solidFill>
+              </a:defRPr>
+            </a:pPr>
+            <a:r>
+              <a:t>10</a:t>
+            </a:r>
+          </a:p>
+          <a:p>
+            <a:pPr algn="ctr">
+              <a:defRPr sz="1200">
+                <a:solidFill>
+                  <a:srgbClr val="1C1E21"/>
+                </a:solidFill>
+              </a:defRPr>
+            </a:pPr>
+            <a:r>
+              <a:t>external integrations</a:t>
+            </a:r>
+          </a:p>
+        </p:txBody>
+      </p:sp>
+      <p:sp>
+        <p:nvSpPr>
+          <p:cNvPr id="9" name="Rounded Rectangle 8"/>
+          <p:cNvSpPr/>
+          <p:nvPr/>
+        </p:nvSpPr>
+        <p:spPr>
+          <a:xfrm>
+            <a:off x="457200" y="3474720"/>
+            <a:ext cx="2651760" cy="1554480"/>
+          </a:xfrm>
+          <a:prstGeom prst="roundRect">
+            <a:avLst/>
+          </a:prstGeom>
+          <a:solidFill>
+            <a:srgbClr val="F3EEFB"/>
+          </a:solidFill>
+          <a:ln w="15875">
+            <a:solidFill>
+              <a:srgbClr val="E3E5E9"/>
+            </a:solidFill>
+          </a:ln>
+          <a:effectLst/>
+        </p:spPr>
+        <p:style>
+          <a:lnRef idx="1">
+            <a:schemeClr val="accent1"/>
+          </a:lnRef>
+          <a:fillRef idx="3">
+            <a:schemeClr val="accent1"/>
+          </a:fillRef>
+          <a:effectRef idx="2">
+            <a:schemeClr val="accent1"/>
+          </a:effectRef>
+          <a:fontRef idx="minor">
+            <a:schemeClr val="lt1"/>
+          </a:fontRef>
+        </p:style>
+        <p:txBody>
+          <a:bodyPr rtlCol="0" anchor="ctr" wrap="square" lIns="45720" rIns="45720"/>
+          <a:lstStyle/>
+          <a:p>
+            <a:pPr algn="ctr">
+              <a:defRPr sz="3400" b="1">
+                <a:solidFill>
+                  <a:srgbClr val="6D28D9"/>
+                </a:solidFill>
+              </a:defRPr>
+            </a:pPr>
+            <a:r>
+              <a:t>47</a:t>
+            </a:r>
+          </a:p>
+          <a:p>
+            <a:pPr algn="ctr">
+              <a:defRPr sz="1200">
+                <a:solidFill>
+                  <a:srgbClr val="1C1E21"/>
+                </a:solidFill>
+              </a:defRPr>
+            </a:pPr>
+            <a:r>
+              <a:t>static check IDs</a:t>
+            </a:r>
+            <a:br/>
+            <a:r>
+              <a:t>across 22 YAML catalogs</a:t>
+            </a:r>
+          </a:p>
+        </p:txBody>
+      </p:sp>
+      <p:sp>
+        <p:nvSpPr>
+          <p:cNvPr id="10" name="Rounded Rectangle 9"/>
+          <p:cNvSpPr/>
+          <p:nvPr/>
+        </p:nvSpPr>
+        <p:spPr>
+          <a:xfrm>
+            <a:off x="3246120" y="3474720"/>
+            <a:ext cx="2651760" cy="1554480"/>
+          </a:xfrm>
+          <a:prstGeom prst="roundRect">
+            <a:avLst/>
+          </a:prstGeom>
+          <a:solidFill>
+            <a:srgbClr val="F3EEFB"/>
+          </a:solidFill>
+          <a:ln w="15875">
+            <a:solidFill>
+              <a:srgbClr val="E3E5E9"/>
+            </a:solidFill>
+          </a:ln>
+          <a:effectLst/>
+        </p:spPr>
+        <p:style>
+          <a:lnRef idx="1">
+            <a:schemeClr val="accent1"/>
+          </a:lnRef>
+          <a:fillRef idx="3">
+            <a:schemeClr val="accent1"/>
+          </a:fillRef>
+          <a:effectRef idx="2">
+            <a:schemeClr val="accent1"/>
+          </a:effectRef>
+          <a:fontRef idx="minor">
+            <a:schemeClr val="lt1"/>
+          </a:fontRef>
+        </p:style>
+        <p:txBody>
+          <a:bodyPr rtlCol="0" anchor="ctr" wrap="square" lIns="45720" rIns="45720"/>
+          <a:lstStyle/>
+          <a:p>
+            <a:pPr algn="ctr">
+              <a:defRPr sz="3400" b="1">
+                <a:solidFill>
+                  <a:srgbClr val="6D28D9"/>
+                </a:solidFill>
+              </a:defRPr>
+            </a:pPr>
+            <a:r>
+              <a:t>39</a:t>
+            </a:r>
+          </a:p>
+          <a:p>
+            <a:pPr algn="ctr">
+              <a:defRPr sz="1200">
+                <a:solidFill>
+                  <a:srgbClr val="1C1E21"/>
+                </a:solidFill>
+              </a:defRPr>
+            </a:pPr>
+            <a:r>
+              <a:t>Alembic migrations</a:t>
+            </a:r>
+          </a:p>
+        </p:txBody>
+      </p:sp>
+      <p:sp>
+        <p:nvSpPr>
+          <p:cNvPr id="11" name="Rounded Rectangle 10"/>
+          <p:cNvSpPr/>
+          <p:nvPr/>
+        </p:nvSpPr>
+        <p:spPr>
+          <a:xfrm>
+            <a:off x="6035040" y="3474720"/>
+            <a:ext cx="2651760" cy="1554480"/>
+          </a:xfrm>
+          <a:prstGeom prst="roundRect">
+            <a:avLst/>
+          </a:prstGeom>
+          <a:solidFill>
+            <a:srgbClr val="F3EEFB"/>
+          </a:solidFill>
+          <a:ln w="15875">
+            <a:solidFill>
+              <a:srgbClr val="E3E5E9"/>
+            </a:solidFill>
+          </a:ln>
+          <a:effectLst/>
+        </p:spPr>
+        <p:style>
+          <a:lnRef idx="1">
+            <a:schemeClr val="accent1"/>
+          </a:lnRef>
+          <a:fillRef idx="3">
+            <a:schemeClr val="accent1"/>
+          </a:fillRef>
+          <a:effectRef idx="2">
+            <a:schemeClr val="accent1"/>
+          </a:effectRef>
+          <a:fontRef idx="minor">
+            <a:schemeClr val="lt1"/>
+          </a:fontRef>
+        </p:style>
+        <p:txBody>
+          <a:bodyPr rtlCol="0" anchor="ctr" wrap="square" lIns="45720" rIns="45720"/>
+          <a:lstStyle/>
+          <a:p>
+            <a:pPr algn="ctr">
+              <a:defRPr sz="3400" b="1">
+                <a:solidFill>
+                  <a:srgbClr val="6D28D9"/>
+                </a:solidFill>
+              </a:defRPr>
+            </a:pPr>
+            <a:r>
+              <a:t>21×4</a:t>
+            </a:r>
+          </a:p>
+          <a:p>
+            <a:pPr algn="ctr">
+              <a:defRPr sz="1200">
+                <a:solidFill>
+                  <a:srgbClr val="1C1E21"/>
+                </a:solidFill>
+              </a:defRPr>
+            </a:pPr>
+            <a:r>
+              <a:t>RBAC resources × actions</a:t>
+            </a:r>
+          </a:p>
+        </p:txBody>
+      </p:sp>
+      <p:sp>
+        <p:nvSpPr>
+          <p:cNvPr id="12" name="Rounded Rectangle 11"/>
+          <p:cNvSpPr/>
+          <p:nvPr/>
+        </p:nvSpPr>
+        <p:spPr>
+          <a:xfrm>
+            <a:off x="8823960" y="3474720"/>
+            <a:ext cx="2651760" cy="1554480"/>
+          </a:xfrm>
+          <a:prstGeom prst="roundRect">
+            <a:avLst/>
+          </a:prstGeom>
+          <a:solidFill>
+            <a:srgbClr val="F3EEFB"/>
+          </a:solidFill>
+          <a:ln w="15875">
+            <a:solidFill>
+              <a:srgbClr val="E3E5E9"/>
+            </a:solidFill>
+          </a:ln>
+          <a:effectLst/>
+        </p:spPr>
+        <p:style>
+          <a:lnRef idx="1">
+            <a:schemeClr val="accent1"/>
+          </a:lnRef>
+          <a:fillRef idx="3">
+            <a:schemeClr val="accent1"/>
+          </a:fillRef>
+          <a:effectRef idx="2">
+            <a:schemeClr val="accent1"/>
+          </a:effectRef>
+          <a:fontRef idx="minor">
+            <a:schemeClr val="lt1"/>
+          </a:fontRef>
+        </p:style>
+        <p:txBody>
+          <a:bodyPr rtlCol="0" anchor="ctr" wrap="square" lIns="45720" rIns="45720"/>
+          <a:lstStyle/>
+          <a:p>
+            <a:pPr algn="ctr">
+              <a:defRPr sz="3400" b="1">
+                <a:solidFill>
+                  <a:srgbClr val="6D28D9"/>
+                </a:solidFill>
+              </a:defRPr>
+            </a:pPr>
+            <a:r>
+              <a:t>721</a:t>
+            </a:r>
+          </a:p>
+          <a:p>
+            <a:pPr algn="ctr">
+              <a:defRPr sz="1200">
+                <a:solidFill>
+                  <a:srgbClr val="1C1E21"/>
+                </a:solidFill>
+              </a:defRPr>
+            </a:pPr>
+            <a:r>
+              <a:t>tests across 126 files</a:t>
+            </a:r>
+          </a:p>
+        </p:txBody>
+      </p:sp>
+      <p:sp>
+        <p:nvSpPr>
+          <p:cNvPr id="13" name="TextBox 12"/>
           <p:cNvSpPr txBox="1"/>
           <p:nvPr/>
         </p:nvSpPr>
         <p:spPr>
           <a:xfrm>
-            <a:off x="777240" y="1737360"/>
-            <a:ext cx="4937760" cy="4114800"/>
-          </a:xfrm>
-          <a:prstGeom prst="rect">
-            <a:avLst/>
-          </a:prstGeom>
-          <a:noFill/>
-        </p:spPr>
-        <p:txBody>
-          <a:bodyPr wrap="square">
-            <a:spAutoFit/>
-          </a:bodyPr>
-          <a:lstStyle/>
-          <a:p>
-            <a:pPr>
-              <a:defRPr b="1" sz="1600">
-                <a:solidFill>
-                  <a:srgbClr val="6D28D9"/>
-                </a:solidFill>
-              </a:defRPr>
-            </a:pPr>
-            <a:r>
-              <a:t>Built less than originally specified</a:t>
-            </a:r>
-          </a:p>
-          <a:p>
-            <a:pPr>
-              <a:spcAft>
-                <a:spcPts val="700"/>
-              </a:spcAft>
-              <a:defRPr sz="1300"/>
-            </a:pPr>
-            <a:r>
-              <a:t>•  Pre-scan authorization gate — built, then fully removed</a:t>
-            </a:r>
-          </a:p>
-          <a:p>
-            <a:pPr>
-              <a:spcAft>
-                <a:spcPts val="700"/>
-              </a:spcAft>
-              <a:defRPr sz="1300"/>
-            </a:pPr>
-            <a:r>
-              <a:t>•  Human-in-the-loop approval checkpoints — not built</a:t>
-            </a:r>
-          </a:p>
-          <a:p>
-            <a:pPr>
-              <a:spcAft>
-                <a:spcPts val="700"/>
-              </a:spcAft>
-              <a:defRPr sz="1300"/>
-            </a:pPr>
-            <a:r>
-              <a:t>•  Smart Scan graph-level routing — only one narrow case (SSTI)</a:t>
-            </a:r>
-          </a:p>
-          <a:p>
-            <a:pPr>
-              <a:spcAft>
-                <a:spcPts val="700"/>
-              </a:spcAft>
-              <a:defRPr sz="1300"/>
-            </a:pPr>
-            <a:r>
-              <a:t>•  Orchestration engine — LangGraph, not Temporal.io (the spec's primary recommendation)</a:t>
-            </a:r>
-          </a:p>
-          <a:p>
-            <a:pPr>
-              <a:spcAft>
-                <a:spcPts val="700"/>
-              </a:spcAft>
-              <a:defRPr sz="1300"/>
-            </a:pPr>
-            <a:r>
-              <a:t>•  Depth slider (Quick/Standard/Deep) — not built</a:t>
-            </a:r>
-          </a:p>
-          <a:p>
-            <a:pPr>
-              <a:spcAft>
-                <a:spcPts val="700"/>
-              </a:spcAft>
-              <a:defRPr sz="1300"/>
-            </a:pPr>
-            <a:r>
-              <a:t>•  Cross-credential-set result caching — not built</a:t>
-            </a:r>
-          </a:p>
-        </p:txBody>
-      </p:sp>
-      <p:sp>
-        <p:nvSpPr>
-          <p:cNvPr id="8" name="TextBox 7"/>
-          <p:cNvSpPr txBox="1"/>
-          <p:nvPr/>
-        </p:nvSpPr>
-        <p:spPr>
-          <a:xfrm>
-            <a:off x="6446520" y="1737360"/>
-            <a:ext cx="4937760" cy="4114800"/>
-          </a:xfrm>
-          <a:prstGeom prst="rect">
-            <a:avLst/>
-          </a:prstGeom>
-          <a:noFill/>
-        </p:spPr>
-        <p:txBody>
-          <a:bodyPr wrap="square">
-            <a:spAutoFit/>
-          </a:bodyPr>
-          <a:lstStyle/>
-          <a:p>
-            <a:pPr>
-              <a:defRPr b="1" sz="1600">
-                <a:solidFill>
-                  <a:srgbClr val="6D28D9"/>
-                </a:solidFill>
-              </a:defRPr>
-            </a:pPr>
-            <a:r>
-              <a:t>Built beyond what was specified</a:t>
-            </a:r>
-          </a:p>
-          <a:p>
-            <a:pPr>
-              <a:spcAft>
-                <a:spcPts val="700"/>
-              </a:spcAft>
-              <a:defRPr sz="1300"/>
-            </a:pPr>
-            <a:r>
-              <a:t>•  VGS integration — spec asked for webhook push only; shipped three modes (webhook, native workspace, per-scan-run export)</a:t>
-            </a:r>
-          </a:p>
-          <a:p>
-            <a:pPr>
-              <a:spcAft>
-                <a:spcPts val="700"/>
-              </a:spcAft>
-              <a:defRPr sz="1300"/>
-            </a:pPr>
-            <a:r>
-              <a:t>•  Image-polyglot file-upload bypass technique</a:t>
-            </a:r>
-          </a:p>
-          <a:p>
-            <a:pPr>
-              <a:spcAft>
-                <a:spcPts val="700"/>
-              </a:spcAft>
-              <a:defRPr sz="1300"/>
-            </a:pPr>
-            <a:r>
-              <a:t>•  "Load from PortSwigger" scraper integration</a:t>
-            </a:r>
-          </a:p>
-          <a:p>
-            <a:pPr>
-              <a:spcAft>
-                <a:spcPts val="700"/>
-              </a:spcAft>
-              <a:defRPr sz="1300"/>
-            </a:pPr>
-            <a:r>
-              <a:t>•  UI-only, per-org default AI provider configuration</a:t>
-            </a:r>
-          </a:p>
-          <a:p>
-            <a:pPr>
-              <a:spcAft>
-                <a:spcPts val="700"/>
-              </a:spcAft>
-              <a:defRPr sz="1300"/>
-            </a:pPr>
-            <a:r>
-              <a:t>•  A genuine conversational Microsoft Teams bot</a:t>
-            </a:r>
-          </a:p>
-          <a:p>
-            <a:pPr>
-              <a:spcAft>
-                <a:spcPts val="700"/>
-              </a:spcAft>
-              <a:defRPr sz="1300"/>
-            </a:pPr>
-            <a:r>
-              <a:t>•  Two independent login-macro recorders, four checks ported from a sibling DAST project, and (2nd attempt) automatic, zero-config per-task model tiering</a:t>
-            </a:r>
-          </a:p>
-        </p:txBody>
-      </p:sp>
-      <p:sp>
-        <p:nvSpPr>
-          <p:cNvPr id="9" name="TextBox 8"/>
-          <p:cNvSpPr txBox="1"/>
-          <p:nvPr/>
-        </p:nvSpPr>
-        <p:spPr>
-          <a:xfrm>
-            <a:off x="11094415" y="6400800"/>
-            <a:ext cx="822960" cy="320040"/>
+            <a:off x="548640" y="6035040"/>
+            <a:ext cx="11094415" cy="457200"/>
           </a:xfrm>
           <a:prstGeom prst="rect">
             <a:avLst/>
@@ -7137,6 +6974,41 @@
           </a:bodyPr>
           <a:lstStyle/>
           <a:p>
+            <a:pPr algn="ctr">
+              <a:defRPr i="1" sz="1200">
+                <a:solidFill>
+                  <a:srgbClr val="5B6270"/>
+                </a:solidFill>
+              </a:defRPr>
+            </a:pPr>
+            <a:r>
+              <a:t>Verified by direct code inspection and by running the test collector — not estimated.</a:t>
+            </a:r>
+          </a:p>
+        </p:txBody>
+      </p:sp>
+      <p:sp>
+        <p:nvSpPr>
+          <p:cNvPr id="14" name="TextBox 13"/>
+          <p:cNvSpPr txBox="1"/>
+          <p:nvPr/>
+        </p:nvSpPr>
+        <p:spPr>
+          <a:xfrm>
+            <a:off x="11094415" y="6400800"/>
+            <a:ext cx="822960" cy="320040"/>
+          </a:xfrm>
+          <a:prstGeom prst="rect">
+            <a:avLst/>
+          </a:prstGeom>
+          <a:noFill/>
+        </p:spPr>
+        <p:txBody>
+          <a:bodyPr wrap="none">
+            <a:spAutoFit/>
+          </a:bodyPr>
+          <a:lstStyle/>
+          <a:p>
             <a:pPr algn="r">
               <a:defRPr sz="1000">
                 <a:solidFill>
@@ -7152,7 +7024,7 @@
       </p:sp>
       <p:sp>
         <p:nvSpPr>
-          <p:cNvPr id="10" name="TextBox 9"/>
+          <p:cNvPr id="15" name="TextBox 14"/>
           <p:cNvSpPr txBox="1"/>
           <p:nvPr/>
         </p:nvSpPr>
@@ -7285,7 +7157,7 @@
               </a:defRPr>
             </a:pPr>
             <a:r>
-              <a:t>QUALITY</a:t>
+              <a:t>AN HONEST LOOK</a:t>
             </a:r>
           </a:p>
         </p:txBody>
@@ -7321,21 +7193,125 @@
               </a:defRPr>
             </a:pPr>
             <a:r>
-              <a:t>Testing discipline</a:t>
-            </a:r>
-          </a:p>
-        </p:txBody>
-      </p:sp>
-      <p:sp>
-        <p:nvSpPr>
-          <p:cNvPr id="5" name="TextBox 4"/>
+              <a:t>Spec vs. reality</a:t>
+            </a:r>
+          </a:p>
+        </p:txBody>
+      </p:sp>
+      <p:sp>
+        <p:nvSpPr>
+          <p:cNvPr id="5" name="Rounded Rectangle 4"/>
+          <p:cNvSpPr/>
+          <p:nvPr/>
+        </p:nvSpPr>
+        <p:spPr>
+          <a:xfrm>
+            <a:off x="548640" y="1554480"/>
+            <a:ext cx="5394960" cy="4480560"/>
+          </a:xfrm>
+          <a:prstGeom prst="roundRect">
+            <a:avLst/>
+          </a:prstGeom>
+          <a:solidFill>
+            <a:srgbClr val="F3EEFB"/>
+          </a:solidFill>
+          <a:ln w="15875">
+            <a:solidFill>
+              <a:srgbClr val="6D28D9"/>
+            </a:solidFill>
+          </a:ln>
+          <a:effectLst/>
+        </p:spPr>
+        <p:style>
+          <a:lnRef idx="1">
+            <a:schemeClr val="accent1"/>
+          </a:lnRef>
+          <a:fillRef idx="3">
+            <a:schemeClr val="accent1"/>
+          </a:fillRef>
+          <a:effectRef idx="2">
+            <a:schemeClr val="accent1"/>
+          </a:effectRef>
+          <a:fontRef idx="minor">
+            <a:schemeClr val="lt1"/>
+          </a:fontRef>
+        </p:style>
+        <p:txBody>
+          <a:bodyPr rtlCol="0" anchor="ctr" wrap="square" lIns="45720" rIns="45720"/>
+          <a:lstStyle/>
+          <a:p>
+            <a:pPr algn="ctr">
+              <a:defRPr sz="1300" b="0">
+                <a:solidFill>
+                  <a:srgbClr val="1C1E21"/>
+                </a:solidFill>
+              </a:defRPr>
+            </a:pPr>
+          </a:p>
+        </p:txBody>
+      </p:sp>
+      <p:sp>
+        <p:nvSpPr>
+          <p:cNvPr id="6" name="Rounded Rectangle 5"/>
+          <p:cNvSpPr/>
+          <p:nvPr/>
+        </p:nvSpPr>
+        <p:spPr>
+          <a:xfrm>
+            <a:off x="6217920" y="1554480"/>
+            <a:ext cx="5394960" cy="4480560"/>
+          </a:xfrm>
+          <a:prstGeom prst="roundRect">
+            <a:avLst/>
+          </a:prstGeom>
+          <a:solidFill>
+            <a:srgbClr val="F3EEFB"/>
+          </a:solidFill>
+          <a:ln w="15875">
+            <a:solidFill>
+              <a:srgbClr val="6D28D9"/>
+            </a:solidFill>
+          </a:ln>
+          <a:effectLst/>
+        </p:spPr>
+        <p:style>
+          <a:lnRef idx="1">
+            <a:schemeClr val="accent1"/>
+          </a:lnRef>
+          <a:fillRef idx="3">
+            <a:schemeClr val="accent1"/>
+          </a:fillRef>
+          <a:effectRef idx="2">
+            <a:schemeClr val="accent1"/>
+          </a:effectRef>
+          <a:fontRef idx="minor">
+            <a:schemeClr val="lt1"/>
+          </a:fontRef>
+        </p:style>
+        <p:txBody>
+          <a:bodyPr rtlCol="0" anchor="ctr" wrap="square" lIns="45720" rIns="45720"/>
+          <a:lstStyle/>
+          <a:p>
+            <a:pPr algn="ctr">
+              <a:defRPr sz="1300" b="0">
+                <a:solidFill>
+                  <a:srgbClr val="1C1E21"/>
+                </a:solidFill>
+              </a:defRPr>
+            </a:pPr>
+          </a:p>
+        </p:txBody>
+      </p:sp>
+      <p:sp>
+        <p:nvSpPr>
+          <p:cNvPr id="7" name="TextBox 6"/>
           <p:cNvSpPr txBox="1"/>
           <p:nvPr/>
         </p:nvSpPr>
         <p:spPr>
           <a:xfrm>
-            <a:off x="640080" y="1645920"/>
-            <a:ext cx="10911535" cy="4572000"/>
+            <a:off x="777240" y="1737360"/>
+            <a:ext cx="4937760" cy="4114800"/>
           </a:xfrm>
           <a:prstGeom prst="rect">
             <a:avLst/>
@@ -7349,81 +7325,188 @@
           <a:lstStyle/>
           <a:p>
             <a:pPr>
-              <a:lnSpc>
-                <a:spcPct val="125000"/>
-              </a:lnSpc>
+              <a:defRPr b="1" sz="1600">
+                <a:solidFill>
+                  <a:srgbClr val="6D28D9"/>
+                </a:solidFill>
+              </a:defRPr>
+            </a:pPr>
+            <a:r>
+              <a:t>Built less than originally specified</a:t>
+            </a:r>
+          </a:p>
+          <a:p>
+            <a:pPr>
               <a:spcAft>
-                <a:spcPts val="1000"/>
+                <a:spcPts val="700"/>
               </a:spcAft>
-              <a:defRPr sz="1800" b="0">
-                <a:solidFill>
-                  <a:srgbClr val="1C1E21"/>
-                </a:solidFill>
-              </a:defRPr>
-            </a:pPr>
-            <a:r>
-              <a:t>•  667 tests across 119 files, confirmed via pytest --collect-only — real fixtures over mocks: local HTTP servers, a real headless browser, real cryptographic round-trips</a:t>
-            </a:r>
-          </a:p>
-          <a:p>
-            <a:pPr>
-              <a:lnSpc>
-                <a:spcPct val="125000"/>
-              </a:lnSpc>
+              <a:defRPr sz="1300"/>
+            </a:pPr>
+            <a:r>
+              <a:t>•  Pre-scan authorization gate — built, then fully removed</a:t>
+            </a:r>
+          </a:p>
+          <a:p>
+            <a:pPr>
               <a:spcAft>
-                <a:spcPts val="1000"/>
+                <a:spcPts val="700"/>
               </a:spcAft>
-              <a:defRPr sz="1800" b="0">
-                <a:solidFill>
-                  <a:srgbClr val="1C1E21"/>
-                </a:solidFill>
-              </a:defRPr>
-            </a:pPr>
-            <a:r>
-              <a:t>•  Live-validated against OWASP Juice Shop and a real DVWA instance across all four security levels</a:t>
-            </a:r>
-          </a:p>
-          <a:p>
-            <a:pPr>
-              <a:lnSpc>
-                <a:spcPct val="125000"/>
-              </a:lnSpc>
+              <a:defRPr sz="1300"/>
+            </a:pPr>
+            <a:r>
+              <a:t>•  Human-in-the-loop approval checkpoints — not built</a:t>
+            </a:r>
+          </a:p>
+          <a:p>
+            <a:pPr>
               <a:spcAft>
-                <a:spcPts val="1000"/>
+                <a:spcPts val="700"/>
               </a:spcAft>
-              <a:defRPr sz="1800" b="0">
-                <a:solidFill>
-                  <a:srgbClr val="1C1E21"/>
-                </a:solidFill>
-              </a:defRPr>
-            </a:pPr>
-            <a:r>
-              <a:t>•  DVWA "Impossible" correctly produces zero injection/XSS findings; "Medium" correctly yields confirmed SQLi and command injection through the full pipeline</a:t>
-            </a:r>
-          </a:p>
-          <a:p>
-            <a:pPr>
-              <a:lnSpc>
-                <a:spcPct val="125000"/>
-              </a:lnSpc>
+              <a:defRPr sz="1300"/>
+            </a:pPr>
+            <a:r>
+              <a:t>•  Smart Scan graph-level routing — only one narrow case (SSTI)</a:t>
+            </a:r>
+          </a:p>
+          <a:p>
+            <a:pPr>
               <a:spcAft>
-                <a:spcPts val="1000"/>
+                <a:spcPts val="700"/>
               </a:spcAft>
-              <a:defRPr sz="1800" b="0">
-                <a:solidFill>
-                  <a:srgbClr val="1C1E21"/>
-                </a:solidFill>
-              </a:defRPr>
-            </a:pPr>
-            <a:r>
-              <a:t>•  Every bug fix in this system's history was root-caused against a real, running target — not inferred from a stack trace alone</a:t>
-            </a:r>
-          </a:p>
-        </p:txBody>
-      </p:sp>
-      <p:sp>
-        <p:nvSpPr>
-          <p:cNvPr id="6" name="TextBox 5"/>
+              <a:defRPr sz="1300"/>
+            </a:pPr>
+            <a:r>
+              <a:t>•  Orchestration engine — LangGraph, not Temporal.io (the spec's primary recommendation)</a:t>
+            </a:r>
+          </a:p>
+          <a:p>
+            <a:pPr>
+              <a:spcAft>
+                <a:spcPts val="700"/>
+              </a:spcAft>
+              <a:defRPr sz="1300"/>
+            </a:pPr>
+            <a:r>
+              <a:t>•  Depth slider (Quick/Standard/Deep) — not built</a:t>
+            </a:r>
+          </a:p>
+          <a:p>
+            <a:pPr>
+              <a:spcAft>
+                <a:spcPts val="700"/>
+              </a:spcAft>
+              <a:defRPr sz="1300"/>
+            </a:pPr>
+            <a:r>
+              <a:t>•  Cross-credential-set result caching — not built</a:t>
+            </a:r>
+          </a:p>
+        </p:txBody>
+      </p:sp>
+      <p:sp>
+        <p:nvSpPr>
+          <p:cNvPr id="8" name="TextBox 7"/>
+          <p:cNvSpPr txBox="1"/>
+          <p:nvPr/>
+        </p:nvSpPr>
+        <p:spPr>
+          <a:xfrm>
+            <a:off x="6446520" y="1737360"/>
+            <a:ext cx="4937760" cy="4114800"/>
+          </a:xfrm>
+          <a:prstGeom prst="rect">
+            <a:avLst/>
+          </a:prstGeom>
+          <a:noFill/>
+        </p:spPr>
+        <p:txBody>
+          <a:bodyPr wrap="square">
+            <a:spAutoFit/>
+          </a:bodyPr>
+          <a:lstStyle/>
+          <a:p>
+            <a:pPr>
+              <a:defRPr b="1" sz="1600">
+                <a:solidFill>
+                  <a:srgbClr val="6D28D9"/>
+                </a:solidFill>
+              </a:defRPr>
+            </a:pPr>
+            <a:r>
+              <a:t>Built beyond what was specified</a:t>
+            </a:r>
+          </a:p>
+          <a:p>
+            <a:pPr>
+              <a:spcAft>
+                <a:spcPts val="700"/>
+              </a:spcAft>
+              <a:defRPr sz="1300"/>
+            </a:pPr>
+            <a:r>
+              <a:t>•  VGS integration — spec asked for webhook push only; shipped three modes (webhook, native workspace, per-scan-run export)</a:t>
+            </a:r>
+          </a:p>
+          <a:p>
+            <a:pPr>
+              <a:spcAft>
+                <a:spcPts val="700"/>
+              </a:spcAft>
+              <a:defRPr sz="1300"/>
+            </a:pPr>
+            <a:r>
+              <a:t>•  Image-polyglot file-upload bypass technique</a:t>
+            </a:r>
+          </a:p>
+          <a:p>
+            <a:pPr>
+              <a:spcAft>
+                <a:spcPts val="700"/>
+              </a:spcAft>
+              <a:defRPr sz="1300"/>
+            </a:pPr>
+            <a:r>
+              <a:t>•  "Load from PortSwigger" scraper integration</a:t>
+            </a:r>
+          </a:p>
+          <a:p>
+            <a:pPr>
+              <a:spcAft>
+                <a:spcPts val="700"/>
+              </a:spcAft>
+              <a:defRPr sz="1300"/>
+            </a:pPr>
+            <a:r>
+              <a:t>•  UI-only, per-org default AI provider configuration</a:t>
+            </a:r>
+          </a:p>
+          <a:p>
+            <a:pPr>
+              <a:spcAft>
+                <a:spcPts val="700"/>
+              </a:spcAft>
+              <a:defRPr sz="1300"/>
+            </a:pPr>
+            <a:r>
+              <a:t>•  A genuine conversational Microsoft Teams bot</a:t>
+            </a:r>
+          </a:p>
+          <a:p>
+            <a:pPr>
+              <a:spcAft>
+                <a:spcPts val="700"/>
+              </a:spcAft>
+              <a:defRPr sz="1300"/>
+            </a:pPr>
+            <a:r>
+              <a:t>•  Two independent login-macro recorders, four checks ported from a sibling DAST project, and (2nd attempt) automatic, zero-config per-task model tiering</a:t>
+            </a:r>
+          </a:p>
+        </p:txBody>
+      </p:sp>
+      <p:sp>
+        <p:nvSpPr>
+          <p:cNvPr id="9" name="TextBox 8"/>
           <p:cNvSpPr txBox="1"/>
           <p:nvPr/>
         </p:nvSpPr>
@@ -7458,7 +7541,7 @@
       </p:sp>
       <p:sp>
         <p:nvSpPr>
-          <p:cNvPr id="7" name="TextBox 6"/>
+          <p:cNvPr id="10" name="TextBox 9"/>
           <p:cNvSpPr txBox="1"/>
           <p:nvPr/>
         </p:nvSpPr>
@@ -7776,7 +7859,7 @@
               </a:defRPr>
             </a:pPr>
             <a:r>
-              <a:t>•  VGS integration, enterprise hardening, and deployment</a:t>
+              <a:t>•  VGS integration, enterprise hardening, data handling &amp; security, and deployment</a:t>
             </a:r>
           </a:p>
           <a:p>
@@ -7987,7 +8070,7 @@
               </a:defRPr>
             </a:pPr>
             <a:r>
-              <a:t>ROADMAP</a:t>
+              <a:t>QUALITY</a:t>
             </a:r>
           </a:p>
         </p:txBody>
@@ -8023,7 +8106,7 @@
               </a:defRPr>
             </a:pPr>
             <a:r>
-              <a:t>What's next</a:t>
+              <a:t>Testing discipline</a:t>
             </a:r>
           </a:p>
         </p:txBody>
@@ -8064,7 +8147,7 @@
               </a:defRPr>
             </a:pPr>
             <a:r>
-              <a:t>•  Build out Smart Scan's graph-level routing — use the fingerprint to actually skip irrelevant node scheduling, not just display it</a:t>
+              <a:t>•  667 tests across 119 files, confirmed via pytest --collect-only — real fixtures over mocks: local HTTP servers, a real headless browser, real cryptographic round-trips</a:t>
             </a:r>
           </a:p>
           <a:p>
@@ -8082,7 +8165,7 @@
               </a:defRPr>
             </a:pPr>
             <a:r>
-              <a:t>•  A depth/intensity profile (Quick / Standard / Deep) as a scan-trigger option</a:t>
+              <a:t>•  Live-validated against OWASP Juice Shop and a real DVWA instance across all four security levels</a:t>
             </a:r>
           </a:p>
           <a:p>
@@ -8100,7 +8183,7 @@
               </a:defRPr>
             </a:pPr>
             <a:r>
-              <a:t>•  Extend automatic model tiering to Gemini once its 3.x naming stabilizes past the October 2026 retirement of the 2.5 line</a:t>
+              <a:t>•  DVWA "Impossible" correctly produces zero injection/XSS findings; "Medium" correctly yields confirmed SQLi and command injection through the full pipeline</a:t>
             </a:r>
           </a:p>
           <a:p>
@@ -8118,25 +8201,7 @@
               </a:defRPr>
             </a:pPr>
             <a:r>
-              <a:t>•  A more sophisticated file-upload bypass technique, chaining into a standalone RCE proof</a:t>
-            </a:r>
-          </a:p>
-          <a:p>
-            <a:pPr>
-              <a:lnSpc>
-                <a:spcPct val="125000"/>
-              </a:lnSpc>
-              <a:spcAft>
-                <a:spcPts val="1000"/>
-              </a:spcAft>
-              <a:defRPr sz="1800" b="0">
-                <a:solidFill>
-                  <a:srgbClr val="1C1E21"/>
-                </a:solidFill>
-              </a:defRPr>
-            </a:pPr>
-            <a:r>
-              <a:t>•  Configurable human-in-the-loop approval checkpoints for the most invasive check categories</a:t>
+              <a:t>•  Every bug fix in this system's history was root-caused against a real, running target — not inferred from a stack trace alone</a:t>
             </a:r>
           </a:p>
         </p:txBody>
@@ -8222,6 +8287,14 @@
 <file path=ppt/slides/slide21.xml><?xml version="1.0" encoding="utf-8"?>
 <p:sld xmlns:a="http://schemas.openxmlformats.org/drawingml/2006/main" xmlns:p="http://schemas.openxmlformats.org/presentationml/2006/main" xmlns:r="http://schemas.openxmlformats.org/officeDocument/2006/relationships">
   <p:cSld>
+    <p:bg>
+      <p:bgPr>
+        <a:solidFill>
+          <a:srgbClr val="FFFFFF"/>
+        </a:solidFill>
+        <a:effectLst/>
+      </p:bgPr>
+    </p:bg>
     <p:spTree>
       <p:nvGrpSpPr>
         <p:cNvPr id="1" name=""/>
@@ -8303,7 +8376,7 @@
               </a:defRPr>
             </a:pPr>
             <a:r>
-              <a:t>COMMON QUESTIONS</a:t>
+              <a:t>ROADMAP</a:t>
             </a:r>
           </a:p>
         </p:txBody>
@@ -8339,7 +8412,7 @@
               </a:defRPr>
             </a:pPr>
             <a:r>
-              <a:t>FAQ</a:t>
+              <a:t>What's next</a:t>
             </a:r>
           </a:p>
         </p:txBody>
@@ -8368,91 +8441,127 @@
           <a:p>
             <a:pPr>
               <a:lnSpc>
-                <a:spcPct val="115000"/>
+                <a:spcPct val="125000"/>
               </a:lnSpc>
               <a:spcAft>
-                <a:spcPts val="700"/>
+                <a:spcPts val="1000"/>
               </a:spcAft>
-              <a:defRPr sz="1400" b="0">
+              <a:defRPr sz="1800" b="0">
                 <a:solidFill>
                   <a:srgbClr val="1C1E21"/>
                 </a:solidFill>
               </a:defRPr>
             </a:pPr>
             <a:r>
-              <a:t>•  How does crawling work? — A Playwright-driven crawler discovers pages/forms/API calls within scope; uploaded traffic (HAR/Burp/Zest) supplements live crawling, it doesn't replace it.</a:t>
+              <a:t>•  Build out Smart Scan's graph-level routing — use the fingerprint to actually skip irrelevant node scheduling, not just display it</a:t>
             </a:r>
           </a:p>
           <a:p>
             <a:pPr>
               <a:lnSpc>
-                <a:spcPct val="115000"/>
+                <a:spcPct val="125000"/>
               </a:lnSpc>
               <a:spcAft>
-                <a:spcPts val="700"/>
+                <a:spcPts val="1000"/>
               </a:spcAft>
-              <a:defRPr sz="1400" b="0">
+              <a:defRPr sz="1800" b="0">
                 <a:solidFill>
                   <a:srgbClr val="1C1E21"/>
                 </a:solidFill>
               </a:defRPr>
             </a:pPr>
             <a:r>
-              <a:t>•  How are vulnerabilities found, and what does AI actually do? — Deterministic HTTP-level probes run first; AI only triages results and helps craft context-aware payloads. AI never single-handedly confirms a finding.</a:t>
+              <a:t>•  A depth/intensity profile (Quick / Standard / Deep) as a scan-trigger option</a:t>
             </a:r>
           </a:p>
           <a:p>
             <a:pPr>
               <a:lnSpc>
-                <a:spcPct val="115000"/>
+                <a:spcPct val="125000"/>
               </a:lnSpc>
               <a:spcAft>
-                <a:spcPts val="700"/>
+                <a:spcPts val="1000"/>
               </a:spcAft>
-              <a:defRPr sz="1400" b="0">
+              <a:defRPr sz="1800" b="0">
                 <a:solidFill>
                   <a:srgbClr val="1C1E21"/>
                 </a:solidFill>
               </a:defRPr>
             </a:pPr>
             <a:r>
-              <a:t>•  How is this different from WebInspect or Checkmarx? — Those are single-pass deterministic scanners; Verdikt pairs the same deterministic probing with LLM-assisted triage and adversarial validation, so only confirmed findings reach a report.</a:t>
+              <a:t>•  Extend automatic model tiering to Gemini once its 3.x naming stabilizes past the October 2026 retirement of the 2.5 line</a:t>
             </a:r>
           </a:p>
           <a:p>
             <a:pPr>
               <a:lnSpc>
-                <a:spcPct val="115000"/>
+                <a:spcPct val="125000"/>
               </a:lnSpc>
               <a:spcAft>
-                <a:spcPts val="700"/>
+                <a:spcPts val="1000"/>
               </a:spcAft>
-              <a:defRPr sz="1400" b="0">
+              <a:defRPr sz="1800" b="0">
                 <a:solidFill>
                   <a:srgbClr val="1C1E21"/>
                 </a:solidFill>
               </a:defRPr>
             </a:pPr>
             <a:r>
-              <a:t>•  If I upload traffic, does it still crawl the live site? — Yes — uploaded traffic and live crawling both run and combine into one scope.</a:t>
+              <a:t>•  A more sophisticated file-upload bypass technique, chaining into a standalone RCE proof</a:t>
             </a:r>
           </a:p>
           <a:p>
             <a:pPr>
               <a:lnSpc>
-                <a:spcPct val="115000"/>
+                <a:spcPct val="125000"/>
               </a:lnSpc>
               <a:spcAft>
-                <a:spcPts val="700"/>
+                <a:spcPts val="1000"/>
               </a:spcAft>
-              <a:defRPr sz="1400" b="0">
+              <a:defRPr sz="1800" b="0">
                 <a:solidFill>
                   <a:srgbClr val="1C1E21"/>
                 </a:solidFill>
               </a:defRPr>
             </a:pPr>
             <a:r>
-              <a:t>•  What's the architecture, and why AI if scans are deterministic? — A 31-node LangGraph DAG per scan: deterministic probe → AI triage → deterministic re-execution → adversarial AI validation. AI expands and interprets; it never decides alone.</a:t>
+              <a:t>•  Configurable human-in-the-loop approval checkpoints for the most invasive check categories</a:t>
+            </a:r>
+          </a:p>
+          <a:p>
+            <a:pPr>
+              <a:lnSpc>
+                <a:spcPct val="125000"/>
+              </a:lnSpc>
+              <a:spcAft>
+                <a:spcPts val="1000"/>
+              </a:spcAft>
+              <a:defRPr sz="1800" b="0">
+                <a:solidFill>
+                  <a:srgbClr val="1C1E21"/>
+                </a:solidFill>
+              </a:defRPr>
+            </a:pPr>
+            <a:r>
+              <a:t>•  ASI02 Tool Misuse's malicious-argument-to-a-real-tool-call half — deferred pending tool/function-manifest introspection to design against</a:t>
+            </a:r>
+          </a:p>
+          <a:p>
+            <a:pPr>
+              <a:lnSpc>
+                <a:spcPct val="125000"/>
+              </a:lnSpc>
+              <a:spcAft>
+                <a:spcPts val="1000"/>
+              </a:spcAft>
+              <a:defRPr sz="1800" b="0">
+                <a:solidFill>
+                  <a:srgbClr val="1C1E21"/>
+                </a:solidFill>
+              </a:defRPr>
+            </a:pPr>
+            <a:r>
+              <a:t>•  Indirect prompt injection via RAG-corpus poisoning for the Chatbot Pentest capability — deferred pending a safe, generic way to plant content into a target's retrieval corpus</a:t>
             </a:r>
           </a:p>
         </p:txBody>
@@ -8536,6 +8645,358 @@
 </file>
 
 <file path=ppt/slides/slide22.xml><?xml version="1.0" encoding="utf-8"?>
+<p:sld xmlns:a="http://schemas.openxmlformats.org/drawingml/2006/main" xmlns:p="http://schemas.openxmlformats.org/presentationml/2006/main" xmlns:r="http://schemas.openxmlformats.org/officeDocument/2006/relationships">
+  <p:cSld>
+    <p:spTree>
+      <p:nvGrpSpPr>
+        <p:cNvPr id="1" name=""/>
+        <p:cNvGrpSpPr/>
+        <p:nvPr/>
+      </p:nvGrpSpPr>
+      <p:grpSpPr/>
+      <p:sp>
+        <p:nvSpPr>
+          <p:cNvPr id="2" name="Rectangle 1"/>
+          <p:cNvSpPr/>
+          <p:nvPr/>
+        </p:nvSpPr>
+        <p:spPr>
+          <a:xfrm>
+            <a:off x="0" y="0"/>
+            <a:ext cx="12191695" cy="128016"/>
+          </a:xfrm>
+          <a:prstGeom prst="rect">
+            <a:avLst/>
+          </a:prstGeom>
+          <a:solidFill>
+            <a:srgbClr val="6D28D9"/>
+          </a:solidFill>
+          <a:ln>
+            <a:noFill/>
+          </a:ln>
+          <a:effectLst/>
+        </p:spPr>
+        <p:style>
+          <a:lnRef idx="1">
+            <a:schemeClr val="accent1"/>
+          </a:lnRef>
+          <a:fillRef idx="3">
+            <a:schemeClr val="accent1"/>
+          </a:fillRef>
+          <a:effectRef idx="2">
+            <a:schemeClr val="accent1"/>
+          </a:effectRef>
+          <a:fontRef idx="minor">
+            <a:schemeClr val="lt1"/>
+          </a:fontRef>
+        </p:style>
+        <p:txBody>
+          <a:bodyPr rtlCol="0" anchor="ctr"/>
+          <a:lstStyle/>
+          <a:p>
+            <a:pPr algn="ctr"/>
+          </a:p>
+        </p:txBody>
+      </p:sp>
+      <p:sp>
+        <p:nvSpPr>
+          <p:cNvPr id="3" name="TextBox 2"/>
+          <p:cNvSpPr txBox="1"/>
+          <p:nvPr/>
+        </p:nvSpPr>
+        <p:spPr>
+          <a:xfrm>
+            <a:off x="548640" y="164592"/>
+            <a:ext cx="7315200" cy="320040"/>
+          </a:xfrm>
+          <a:prstGeom prst="rect">
+            <a:avLst/>
+          </a:prstGeom>
+          <a:noFill/>
+        </p:spPr>
+        <p:txBody>
+          <a:bodyPr wrap="none">
+            <a:spAutoFit/>
+          </a:bodyPr>
+          <a:lstStyle/>
+          <a:p>
+            <a:pPr>
+              <a:defRPr sz="1200" b="1">
+                <a:solidFill>
+                  <a:srgbClr val="6D28D9"/>
+                </a:solidFill>
+              </a:defRPr>
+            </a:pPr>
+            <a:r>
+              <a:t>COMMON QUESTIONS</a:t>
+            </a:r>
+          </a:p>
+        </p:txBody>
+      </p:sp>
+      <p:sp>
+        <p:nvSpPr>
+          <p:cNvPr id="4" name="TextBox 3"/>
+          <p:cNvSpPr txBox="1"/>
+          <p:nvPr/>
+        </p:nvSpPr>
+        <p:spPr>
+          <a:xfrm>
+            <a:off x="548640" y="411480"/>
+            <a:ext cx="11094415" cy="822960"/>
+          </a:xfrm>
+          <a:prstGeom prst="rect">
+            <a:avLst/>
+          </a:prstGeom>
+          <a:noFill/>
+        </p:spPr>
+        <p:txBody>
+          <a:bodyPr wrap="square">
+            <a:spAutoFit/>
+          </a:bodyPr>
+          <a:lstStyle/>
+          <a:p>
+            <a:pPr>
+              <a:defRPr sz="2800" b="1">
+                <a:solidFill>
+                  <a:srgbClr val="1C1E21"/>
+                </a:solidFill>
+                <a:latin typeface="Calibri"/>
+              </a:defRPr>
+            </a:pPr>
+            <a:r>
+              <a:t>FAQ</a:t>
+            </a:r>
+          </a:p>
+        </p:txBody>
+      </p:sp>
+      <p:sp>
+        <p:nvSpPr>
+          <p:cNvPr id="5" name="TextBox 4"/>
+          <p:cNvSpPr txBox="1"/>
+          <p:nvPr/>
+        </p:nvSpPr>
+        <p:spPr>
+          <a:xfrm>
+            <a:off x="640080" y="1645920"/>
+            <a:ext cx="10911535" cy="4572000"/>
+          </a:xfrm>
+          <a:prstGeom prst="rect">
+            <a:avLst/>
+          </a:prstGeom>
+          <a:noFill/>
+        </p:spPr>
+        <p:txBody>
+          <a:bodyPr wrap="square">
+            <a:spAutoFit/>
+          </a:bodyPr>
+          <a:lstStyle/>
+          <a:p>
+            <a:pPr>
+              <a:lnSpc>
+                <a:spcPct val="115000"/>
+              </a:lnSpc>
+              <a:spcAft>
+                <a:spcPts val="700"/>
+              </a:spcAft>
+              <a:defRPr sz="1400" b="0">
+                <a:solidFill>
+                  <a:srgbClr val="1C1E21"/>
+                </a:solidFill>
+              </a:defRPr>
+            </a:pPr>
+            <a:r>
+              <a:t>•  How does crawling work? — A Playwright-driven crawler discovers pages/forms/API calls within scope; uploaded traffic (HAR/Burp/Zest) supplements live crawling, it doesn't replace it.</a:t>
+            </a:r>
+          </a:p>
+          <a:p>
+            <a:pPr>
+              <a:lnSpc>
+                <a:spcPct val="115000"/>
+              </a:lnSpc>
+              <a:spcAft>
+                <a:spcPts val="700"/>
+              </a:spcAft>
+              <a:defRPr sz="1400" b="0">
+                <a:solidFill>
+                  <a:srgbClr val="1C1E21"/>
+                </a:solidFill>
+              </a:defRPr>
+            </a:pPr>
+            <a:r>
+              <a:t>•  How are vulnerabilities found, and what does AI actually do? — Deterministic HTTP-level probes run first; AI only triages results and helps craft context-aware payloads. AI never single-handedly confirms a finding.</a:t>
+            </a:r>
+          </a:p>
+          <a:p>
+            <a:pPr>
+              <a:lnSpc>
+                <a:spcPct val="115000"/>
+              </a:lnSpc>
+              <a:spcAft>
+                <a:spcPts val="700"/>
+              </a:spcAft>
+              <a:defRPr sz="1400" b="0">
+                <a:solidFill>
+                  <a:srgbClr val="1C1E21"/>
+                </a:solidFill>
+              </a:defRPr>
+            </a:pPr>
+            <a:r>
+              <a:t>•  How is this different from WebInspect or Checkmarx? — Those are single-pass deterministic scanners; Verdikt pairs the same deterministic probing with LLM-assisted triage and adversarial validation, so only confirmed findings reach a report.</a:t>
+            </a:r>
+          </a:p>
+          <a:p>
+            <a:pPr>
+              <a:lnSpc>
+                <a:spcPct val="115000"/>
+              </a:lnSpc>
+              <a:spcAft>
+                <a:spcPts val="700"/>
+              </a:spcAft>
+              <a:defRPr sz="1400" b="0">
+                <a:solidFill>
+                  <a:srgbClr val="1C1E21"/>
+                </a:solidFill>
+              </a:defRPr>
+            </a:pPr>
+            <a:r>
+              <a:t>•  If I upload traffic, does it still crawl the live site? — Yes — uploaded traffic and live crawling both run and combine into one scope.</a:t>
+            </a:r>
+          </a:p>
+          <a:p>
+            <a:pPr>
+              <a:lnSpc>
+                <a:spcPct val="115000"/>
+              </a:lnSpc>
+              <a:spcAft>
+                <a:spcPts val="700"/>
+              </a:spcAft>
+              <a:defRPr sz="1400" b="0">
+                <a:solidFill>
+                  <a:srgbClr val="1C1E21"/>
+                </a:solidFill>
+              </a:defRPr>
+            </a:pPr>
+            <a:r>
+              <a:t>•  What's the architecture, and why AI if scans are deterministic? — A 31-node LangGraph DAG per scan: deterministic probe → AI triage → deterministic re-execution → adversarial AI validation. AI expands and interprets; it never decides alone.</a:t>
+            </a:r>
+          </a:p>
+          <a:p>
+            <a:pPr>
+              <a:lnSpc>
+                <a:spcPct val="115000"/>
+              </a:lnSpc>
+              <a:spcAft>
+                <a:spcPts val="700"/>
+              </a:spcAft>
+              <a:defRPr sz="1400" b="0">
+                <a:solidFill>
+                  <a:srgbClr val="1C1E21"/>
+                </a:solidFill>
+              </a:defRPr>
+            </a:pPr>
+            <a:r>
+              <a:t>•  Can Verdikt test a chatbot or LLM-backed app? — Yes — configure a ChatbotTarget and it's checked for prompt injection, hidden-context extraction, improper output handling, excessive agency, and code execution, the same conversational text-in/text-out safety envelope as every other AI-judged check.</a:t>
+            </a:r>
+          </a:p>
+          <a:p>
+            <a:pPr>
+              <a:lnSpc>
+                <a:spcPct val="115000"/>
+              </a:lnSpc>
+              <a:spcAft>
+                <a:spcPts val="700"/>
+              </a:spcAft>
+              <a:defRPr sz="1400" b="0">
+                <a:solidFill>
+                  <a:srgbClr val="1C1E21"/>
+                </a:solidFill>
+              </a:defRPr>
+            </a:pPr>
+            <a:r>
+              <a:t>•  Can I save a custom auth header on a credential? — Yes — extra_headers forces a static header (e.g. X-API-Key) onto every request for that credential, layered on top of any login type including a recorded macro, not just bearer tokens.</a:t>
+            </a:r>
+          </a:p>
+        </p:txBody>
+      </p:sp>
+      <p:sp>
+        <p:nvSpPr>
+          <p:cNvPr id="6" name="TextBox 5"/>
+          <p:cNvSpPr txBox="1"/>
+          <p:nvPr/>
+        </p:nvSpPr>
+        <p:spPr>
+          <a:xfrm>
+            <a:off x="11094415" y="6400800"/>
+            <a:ext cx="822960" cy="320040"/>
+          </a:xfrm>
+          <a:prstGeom prst="rect">
+            <a:avLst/>
+          </a:prstGeom>
+          <a:noFill/>
+        </p:spPr>
+        <p:txBody>
+          <a:bodyPr wrap="none">
+            <a:spAutoFit/>
+          </a:bodyPr>
+          <a:lstStyle/>
+          <a:p>
+            <a:pPr algn="r">
+              <a:defRPr sz="1000">
+                <a:solidFill>
+                  <a:srgbClr val="5B6270"/>
+                </a:solidFill>
+              </a:defRPr>
+            </a:pPr>
+            <a:r>
+              <a:t>22</a:t>
+            </a:r>
+          </a:p>
+        </p:txBody>
+      </p:sp>
+      <p:sp>
+        <p:nvSpPr>
+          <p:cNvPr id="7" name="TextBox 6"/>
+          <p:cNvSpPr txBox="1"/>
+          <p:nvPr/>
+        </p:nvSpPr>
+        <p:spPr>
+          <a:xfrm>
+            <a:off x="548640" y="6400800"/>
+            <a:ext cx="2743200" cy="320040"/>
+          </a:xfrm>
+          <a:prstGeom prst="rect">
+            <a:avLst/>
+          </a:prstGeom>
+          <a:noFill/>
+        </p:spPr>
+        <p:txBody>
+          <a:bodyPr wrap="none">
+            <a:spAutoFit/>
+          </a:bodyPr>
+          <a:lstStyle/>
+          <a:p>
+            <a:pPr>
+              <a:defRPr sz="1000">
+                <a:solidFill>
+                  <a:srgbClr val="5B6270"/>
+                </a:solidFill>
+              </a:defRPr>
+            </a:pPr>
+            <a:r>
+              <a:t>Verdikt</a:t>
+            </a:r>
+          </a:p>
+        </p:txBody>
+      </p:sp>
+    </p:spTree>
+  </p:cSld>
+  <p:clrMapOvr>
+    <a:masterClrMapping/>
+  </p:clrMapOvr>
+</p:sld>
+</file>
+
+<file path=ppt/slides/slide23.xml><?xml version="1.0" encoding="utf-8"?>
 <p:sld xmlns:a="http://schemas.openxmlformats.org/drawingml/2006/main" xmlns:p="http://schemas.openxmlformats.org/presentationml/2006/main" xmlns:r="http://schemas.openxmlformats.org/officeDocument/2006/relationships">
   <p:cSld>
     <p:bg>
@@ -10209,7 +10670,7 @@
               </a:defRPr>
             </a:pPr>
             <a:r>
-              <a:t>31 detection agents in the scan graph</a:t>
+              <a:t>35 detection agents in the scan graph</a:t>
             </a:r>
           </a:p>
         </p:txBody>

</xml_diff>